<commit_message>
Refresh course materials: fix errors, stale info, spelling and grammar
- Fix factual errors (Feather M4 product/chip links and specs, oscilloscope
  sweep direction and velocity factor, Berea longitude, gravity units,
  Form 2 optical window, Inventor UI steps, traffic light colors)
- Make Python examples runnable: remove embedded line numbers, fix
  switchLED.py import, rename binkLED.py to blinkLED.py
- Update stale info: Mu retirement, Inventor disk/licensing, Azure
  Notebooks, nbextension, Matplotlib default colormap, Colab badges
- Add all eight sessions to the README
- Spelling and grammar fixes across markdown, notebooks, and Office files

Co-Authored-By: Claude Opus 5.5 <noreply@anthropic.com>
</commit_message>
<xml_diff>
--- a/Session04Soldering/solderingInstructions.pptx
+++ b/Session04Soldering/solderingInstructions.pptx
@@ -17457,7 +17457,7 @@
           <a:p>
             <a:r>
               <a:rPr lang="en-US" dirty="0"/>
-              <a:t>Ventilator</a:t>
+              <a:t>Fume extractor</a:t>
             </a:r>
           </a:p>
           <a:p>
@@ -17993,7 +17993,7 @@
             </a:pPr>
             <a:r>
               <a:rPr lang="en-US" sz="2400" dirty="0"/>
-              <a:t>Use a properly sized point for the soldering job to be completed.</a:t>
+              <a:t>Use a properly sized tip for the soldering job.</a:t>
             </a:r>
           </a:p>
           <a:p>
@@ -18438,11 +18438,11 @@
             <a:pPr lvl="1"/>
             <a:r>
               <a:rPr lang="en-US" dirty="0" err="1"/>
-              <a:t>Pb</a:t>
+              <a:t>Tin, lead (Pb)</a:t>
             </a:r>
             <a:r>
               <a:rPr lang="en-US" dirty="0"/>
-              <a:t>, Tin</a:t>
+              <a:t/>
             </a:r>
           </a:p>
           <a:p>
@@ -18466,7 +18466,7 @@
           <a:p>
             <a:r>
               <a:rPr lang="en-US" dirty="0"/>
-              <a:t>2 types: leaded and Lead Free</a:t>
+              <a:t>2 types: leaded and lead-free</a:t>
             </a:r>
           </a:p>
           <a:p>
@@ -18595,11 +18595,11 @@
           <a:p>
             <a:r>
               <a:rPr lang="en-US" dirty="0" err="1"/>
-              <a:t>Pb</a:t>
+              <a:t>Tin, lead (Pb)</a:t>
             </a:r>
             <a:r>
               <a:rPr lang="en-US" dirty="0"/>
-              <a:t>, Tin</a:t>
+              <a:t/>
             </a:r>
           </a:p>
           <a:p>
@@ -18989,7 +18989,7 @@
               <a:rPr lang="en-US" sz="2400" dirty="0">
                 <a:cs typeface="Arial" charset="0"/>
               </a:rPr>
-              <a:t>Tip temperature 250°C to 280°C</a:t>
+              <a:t>Tip temperature 315°C to 370°C</a:t>
             </a:r>
           </a:p>
         </p:txBody>

</xml_diff>